<commit_message>
AOM 2026 MOC Best Paper Finalist
</commit_message>
<xml_diff>
--- a/images/awards.pptx
+++ b/images/awards.pptx
@@ -5,13 +5,16 @@
     <p:sldMasterId id="2147483696" r:id="rId1"/>
   </p:sldMasterIdLst>
   <p:notesMasterIdLst>
-    <p:notesMasterId r:id="rId6"/>
+    <p:notesMasterId r:id="rId9"/>
   </p:notesMasterIdLst>
   <p:sldIdLst>
-    <p:sldId id="261" r:id="rId2"/>
-    <p:sldId id="260" r:id="rId3"/>
-    <p:sldId id="262" r:id="rId4"/>
-    <p:sldId id="264" r:id="rId5"/>
+    <p:sldId id="266" r:id="rId2"/>
+    <p:sldId id="261" r:id="rId3"/>
+    <p:sldId id="260" r:id="rId4"/>
+    <p:sldId id="265" r:id="rId5"/>
+    <p:sldId id="262" r:id="rId6"/>
+    <p:sldId id="264" r:id="rId7"/>
+    <p:sldId id="267" r:id="rId8"/>
   </p:sldIdLst>
   <p:sldSz cx="1371600" cy="1371600"/>
   <p:notesSz cx="6858000" cy="9144000"/>
@@ -111,6 +114,25 @@
     </a:lvl9pPr>
   </p:defaultTextStyle>
   <p:extLst>
+    <p:ext uri="{521415D9-36F7-43E2-AB2F-B90AF26B5E84}">
+      <p14:sectionLst xmlns:p14="http://schemas.microsoft.com/office/powerpoint/2010/main">
+        <p14:section name="General Templates" id="{110A5458-4D1E-4A0A-9148-7D91FF739F50}">
+          <p14:sldIdLst>
+            <p14:sldId id="266"/>
+            <p14:sldId id="261"/>
+            <p14:sldId id="260"/>
+            <p14:sldId id="265"/>
+            <p14:sldId id="262"/>
+            <p14:sldId id="264"/>
+          </p14:sldIdLst>
+        </p14:section>
+        <p14:section name="Specific Awards" id="{B204BF1A-F5DA-4780-BD4D-6DBA4BFC239A}">
+          <p14:sldIdLst>
+            <p14:sldId id="267"/>
+          </p14:sldIdLst>
+        </p14:section>
+      </p14:sectionLst>
+    </p:ext>
     <p:ext uri="{EFAFB233-063F-42B5-8137-9DF3F51BA10A}">
       <p15:sldGuideLst xmlns:p15="http://schemas.microsoft.com/office/powerpoint/2012/main"/>
     </p:ext>
@@ -200,7 +222,7 @@
           <a:p>
             <a:fld id="{B1913588-C2C1-4AB8-9F0D-04EC72C1EC15}" type="datetimeFigureOut">
               <a:rPr lang="en-US" smtClean="0"/>
-              <a:t>4/16/2026</a:t>
+              <a:t>5/12/2026</a:t>
             </a:fld>
             <a:endParaRPr lang="en-US"/>
           </a:p>
@@ -598,7 +620,7 @@
           <a:p>
             <a:fld id="{B8700A39-06E1-486D-9C71-A159ABBEACA4}" type="datetimeFigureOut">
               <a:rPr lang="en-US" smtClean="0"/>
-              <a:t>4/16/2026</a:t>
+              <a:t>5/12/2026</a:t>
             </a:fld>
             <a:endParaRPr lang="en-US"/>
           </a:p>
@@ -768,7 +790,7 @@
           <a:p>
             <a:fld id="{B8700A39-06E1-486D-9C71-A159ABBEACA4}" type="datetimeFigureOut">
               <a:rPr lang="en-US" smtClean="0"/>
-              <a:t>4/16/2026</a:t>
+              <a:t>5/12/2026</a:t>
             </a:fld>
             <a:endParaRPr lang="en-US"/>
           </a:p>
@@ -948,7 +970,7 @@
           <a:p>
             <a:fld id="{B8700A39-06E1-486D-9C71-A159ABBEACA4}" type="datetimeFigureOut">
               <a:rPr lang="en-US" smtClean="0"/>
-              <a:t>4/16/2026</a:t>
+              <a:t>5/12/2026</a:t>
             </a:fld>
             <a:endParaRPr lang="en-US"/>
           </a:p>
@@ -1118,7 +1140,7 @@
           <a:p>
             <a:fld id="{B8700A39-06E1-486D-9C71-A159ABBEACA4}" type="datetimeFigureOut">
               <a:rPr lang="en-US" smtClean="0"/>
-              <a:t>4/16/2026</a:t>
+              <a:t>5/12/2026</a:t>
             </a:fld>
             <a:endParaRPr lang="en-US"/>
           </a:p>
@@ -1364,7 +1386,7 @@
           <a:p>
             <a:fld id="{B8700A39-06E1-486D-9C71-A159ABBEACA4}" type="datetimeFigureOut">
               <a:rPr lang="en-US" smtClean="0"/>
-              <a:t>4/16/2026</a:t>
+              <a:t>5/12/2026</a:t>
             </a:fld>
             <a:endParaRPr lang="en-US"/>
           </a:p>
@@ -1596,7 +1618,7 @@
           <a:p>
             <a:fld id="{B8700A39-06E1-486D-9C71-A159ABBEACA4}" type="datetimeFigureOut">
               <a:rPr lang="en-US" smtClean="0"/>
-              <a:t>4/16/2026</a:t>
+              <a:t>5/12/2026</a:t>
             </a:fld>
             <a:endParaRPr lang="en-US"/>
           </a:p>
@@ -1963,7 +1985,7 @@
           <a:p>
             <a:fld id="{B8700A39-06E1-486D-9C71-A159ABBEACA4}" type="datetimeFigureOut">
               <a:rPr lang="en-US" smtClean="0"/>
-              <a:t>4/16/2026</a:t>
+              <a:t>5/12/2026</a:t>
             </a:fld>
             <a:endParaRPr lang="en-US"/>
           </a:p>
@@ -2081,7 +2103,7 @@
           <a:p>
             <a:fld id="{B8700A39-06E1-486D-9C71-A159ABBEACA4}" type="datetimeFigureOut">
               <a:rPr lang="en-US" smtClean="0"/>
-              <a:t>4/16/2026</a:t>
+              <a:t>5/12/2026</a:t>
             </a:fld>
             <a:endParaRPr lang="en-US"/>
           </a:p>
@@ -2176,7 +2198,7 @@
           <a:p>
             <a:fld id="{B8700A39-06E1-486D-9C71-A159ABBEACA4}" type="datetimeFigureOut">
               <a:rPr lang="en-US" smtClean="0"/>
-              <a:t>4/16/2026</a:t>
+              <a:t>5/12/2026</a:t>
             </a:fld>
             <a:endParaRPr lang="en-US"/>
           </a:p>
@@ -2453,7 +2475,7 @@
           <a:p>
             <a:fld id="{B8700A39-06E1-486D-9C71-A159ABBEACA4}" type="datetimeFigureOut">
               <a:rPr lang="en-US" smtClean="0"/>
-              <a:t>4/16/2026</a:t>
+              <a:t>5/12/2026</a:t>
             </a:fld>
             <a:endParaRPr lang="en-US"/>
           </a:p>
@@ -2710,7 +2732,7 @@
           <a:p>
             <a:fld id="{B8700A39-06E1-486D-9C71-A159ABBEACA4}" type="datetimeFigureOut">
               <a:rPr lang="en-US" smtClean="0"/>
-              <a:t>4/16/2026</a:t>
+              <a:t>5/12/2026</a:t>
             </a:fld>
             <a:endParaRPr lang="en-US"/>
           </a:p>
@@ -2923,7 +2945,7 @@
           <a:p>
             <a:fld id="{B8700A39-06E1-486D-9C71-A159ABBEACA4}" type="datetimeFigureOut">
               <a:rPr lang="en-US" smtClean="0"/>
-              <a:t>4/16/2026</a:t>
+              <a:t>5/12/2026</a:t>
             </a:fld>
             <a:endParaRPr lang="en-US"/>
           </a:p>
@@ -3319,6 +3341,178 @@
         <p:cNvPr id="1" name="">
           <a:extLst>
             <a:ext uri="{FF2B5EF4-FFF2-40B4-BE49-F238E27FC236}">
+              <a16:creationId xmlns:a16="http://schemas.microsoft.com/office/drawing/2014/main" id="{B9A64974-D1C7-2EFA-93BD-13D5655F7B78}"/>
+            </a:ext>
+          </a:extLst>
+        </p:cNvPr>
+        <p:cNvGrpSpPr/>
+        <p:nvPr/>
+      </p:nvGrpSpPr>
+      <p:grpSpPr>
+        <a:xfrm>
+          <a:off x="0" y="0"/>
+          <a:ext cx="0" cy="0"/>
+          <a:chOff x="0" y="0"/>
+          <a:chExt cx="0" cy="0"/>
+        </a:xfrm>
+      </p:grpSpPr>
+      <p:pic>
+        <p:nvPicPr>
+          <p:cNvPr id="2" name="Graphic 1" descr="Cursor with solid fill">
+            <a:extLst>
+              <a:ext uri="{FF2B5EF4-FFF2-40B4-BE49-F238E27FC236}">
+                <a16:creationId xmlns:a16="http://schemas.microsoft.com/office/drawing/2014/main" id="{434CACE7-7E8B-D2B6-E4B5-497ADEC476EE}"/>
+              </a:ext>
+            </a:extLst>
+          </p:cNvPr>
+          <p:cNvPicPr>
+            <a:picLocks noChangeAspect="1"/>
+          </p:cNvPicPr>
+          <p:nvPr/>
+        </p:nvPicPr>
+        <p:blipFill>
+          <a:blip>
+            <a:extLst>
+              <a:ext uri="{96DAC541-7B7A-43D3-8B79-37D633B846F1}">
+                <asvg:svgBlip xmlns:asvg="http://schemas.microsoft.com/office/drawing/2016/SVG/main" r:embed="rId2"/>
+              </a:ext>
+            </a:extLst>
+          </a:blip>
+          <a:stretch>
+            <a:fillRect/>
+          </a:stretch>
+        </p:blipFill>
+        <p:spPr>
+          <a:xfrm>
+            <a:off x="-2208061" y="720090"/>
+            <a:ext cx="877824" cy="877824"/>
+          </a:xfrm>
+          <a:prstGeom prst="rect">
+            <a:avLst/>
+          </a:prstGeom>
+        </p:spPr>
+      </p:pic>
+      <p:pic>
+        <p:nvPicPr>
+          <p:cNvPr id="3" name="Graphic 2">
+            <a:extLst>
+              <a:ext uri="{FF2B5EF4-FFF2-40B4-BE49-F238E27FC236}">
+                <a16:creationId xmlns:a16="http://schemas.microsoft.com/office/drawing/2014/main" id="{8696FB7E-C96C-DC1C-A455-826B0FAAB3FA}"/>
+              </a:ext>
+            </a:extLst>
+          </p:cNvPr>
+          <p:cNvPicPr>
+            <a:picLocks noChangeAspect="1"/>
+          </p:cNvPicPr>
+          <p:nvPr/>
+        </p:nvPicPr>
+        <p:blipFill>
+          <a:blip>
+            <a:extLst>
+              <a:ext uri="{96DAC541-7B7A-43D3-8B79-37D633B846F1}">
+                <asvg:svgBlip xmlns:asvg="http://schemas.microsoft.com/office/drawing/2016/SVG/main" r:embed="rId3"/>
+              </a:ext>
+            </a:extLst>
+          </a:blip>
+          <a:srcRect/>
+          <a:stretch/>
+        </p:blipFill>
+        <p:spPr>
+          <a:xfrm>
+            <a:off x="0" y="0"/>
+            <a:ext cx="1371600" cy="1371600"/>
+          </a:xfrm>
+          <a:prstGeom prst="rect">
+            <a:avLst/>
+          </a:prstGeom>
+        </p:spPr>
+      </p:pic>
+      <p:sp>
+        <p:nvSpPr>
+          <p:cNvPr id="5" name="TextBox 4">
+            <a:extLst>
+              <a:ext uri="{FF2B5EF4-FFF2-40B4-BE49-F238E27FC236}">
+                <a16:creationId xmlns:a16="http://schemas.microsoft.com/office/drawing/2014/main" id="{2AC721EB-7AA8-D94E-B582-7B945079F9D4}"/>
+              </a:ext>
+            </a:extLst>
+          </p:cNvPr>
+          <p:cNvSpPr txBox="1"/>
+          <p:nvPr/>
+        </p:nvSpPr>
+        <p:spPr>
+          <a:xfrm>
+            <a:off x="340519" y="123943"/>
+            <a:ext cx="685800" cy="685800"/>
+          </a:xfrm>
+          <a:prstGeom prst="rect">
+            <a:avLst/>
+          </a:prstGeom>
+          <a:noFill/>
+        </p:spPr>
+        <p:txBody>
+          <a:bodyPr wrap="square" rtlCol="0" anchor="ctr">
+            <a:noAutofit/>
+          </a:bodyPr>
+          <a:lstStyle/>
+          <a:p>
+            <a:pPr algn="ctr"/>
+            <a:r>
+              <a:rPr lang="en-US" sz="800" b="1" dirty="0">
+                <a:latin typeface="Arial" panose="020B0604020202020204" pitchFamily="34" charset="0"/>
+                <a:cs typeface="Arial" panose="020B0604020202020204" pitchFamily="34" charset="0"/>
+              </a:rPr>
+              <a:t>Best</a:t>
+            </a:r>
+            <a:br>
+              <a:rPr lang="en-US" sz="800" b="1" dirty="0">
+                <a:latin typeface="Arial" panose="020B0604020202020204" pitchFamily="34" charset="0"/>
+                <a:cs typeface="Arial" panose="020B0604020202020204" pitchFamily="34" charset="0"/>
+              </a:rPr>
+            </a:br>
+            <a:r>
+              <a:rPr lang="en-US" sz="800" b="1" dirty="0">
+                <a:latin typeface="Arial" panose="020B0604020202020204" pitchFamily="34" charset="0"/>
+                <a:cs typeface="Arial" panose="020B0604020202020204" pitchFamily="34" charset="0"/>
+              </a:rPr>
+              <a:t>Paper</a:t>
+            </a:r>
+            <a:br>
+              <a:rPr lang="en-US" sz="800" b="1" dirty="0">
+                <a:latin typeface="Arial" panose="020B0604020202020204" pitchFamily="34" charset="0"/>
+                <a:cs typeface="Arial" panose="020B0604020202020204" pitchFamily="34" charset="0"/>
+              </a:rPr>
+            </a:br>
+            <a:r>
+              <a:rPr lang="en-US" sz="800" b="1" dirty="0">
+                <a:latin typeface="Arial" panose="020B0604020202020204" pitchFamily="34" charset="0"/>
+                <a:cs typeface="Arial" panose="020B0604020202020204" pitchFamily="34" charset="0"/>
+              </a:rPr>
+              <a:t>Winner</a:t>
+            </a:r>
+          </a:p>
+        </p:txBody>
+      </p:sp>
+    </p:spTree>
+    <p:extLst>
+      <p:ext uri="{BB962C8B-B14F-4D97-AF65-F5344CB8AC3E}">
+        <p14:creationId xmlns:p14="http://schemas.microsoft.com/office/powerpoint/2010/main" val="603116401"/>
+      </p:ext>
+    </p:extLst>
+  </p:cSld>
+  <p:clrMapOvr>
+    <a:masterClrMapping/>
+  </p:clrMapOvr>
+</p:sld>
+</file>
+
+<file path=ppt/slides/slide2.xml><?xml version="1.0" encoding="utf-8"?>
+<p:sld xmlns:a="http://schemas.openxmlformats.org/drawingml/2006/main" xmlns:r="http://schemas.openxmlformats.org/officeDocument/2006/relationships" xmlns:p="http://schemas.openxmlformats.org/presentationml/2006/main">
+  <p:cSld>
+    <p:spTree>
+      <p:nvGrpSpPr>
+        <p:cNvPr id="1" name="">
+          <a:extLst>
+            <a:ext uri="{FF2B5EF4-FFF2-40B4-BE49-F238E27FC236}">
               <a16:creationId xmlns:a16="http://schemas.microsoft.com/office/drawing/2014/main" id="{4F9D55B6-38B3-4D87-3C13-A32E2F069681}"/>
             </a:ext>
           </a:extLst>
@@ -3483,7 +3677,7 @@
 </p:sld>
 </file>
 
-<file path=ppt/slides/slide2.xml><?xml version="1.0" encoding="utf-8"?>
+<file path=ppt/slides/slide3.xml><?xml version="1.0" encoding="utf-8"?>
 <p:sld xmlns:a="http://schemas.openxmlformats.org/drawingml/2006/main" xmlns:r="http://schemas.openxmlformats.org/officeDocument/2006/relationships" xmlns:p="http://schemas.openxmlformats.org/presentationml/2006/main">
   <p:cSld>
     <p:spTree>
@@ -3655,7 +3849,179 @@
 </p:sld>
 </file>
 
-<file path=ppt/slides/slide3.xml><?xml version="1.0" encoding="utf-8"?>
+<file path=ppt/slides/slide4.xml><?xml version="1.0" encoding="utf-8"?>
+<p:sld xmlns:a="http://schemas.openxmlformats.org/drawingml/2006/main" xmlns:r="http://schemas.openxmlformats.org/officeDocument/2006/relationships" xmlns:p="http://schemas.openxmlformats.org/presentationml/2006/main">
+  <p:cSld>
+    <p:spTree>
+      <p:nvGrpSpPr>
+        <p:cNvPr id="1" name="">
+          <a:extLst>
+            <a:ext uri="{FF2B5EF4-FFF2-40B4-BE49-F238E27FC236}">
+              <a16:creationId xmlns:a16="http://schemas.microsoft.com/office/drawing/2014/main" id="{22E4BE8B-4A36-1EBF-6BB2-551CA9DF495F}"/>
+            </a:ext>
+          </a:extLst>
+        </p:cNvPr>
+        <p:cNvGrpSpPr/>
+        <p:nvPr/>
+      </p:nvGrpSpPr>
+      <p:grpSpPr>
+        <a:xfrm>
+          <a:off x="0" y="0"/>
+          <a:ext cx="0" cy="0"/>
+          <a:chOff x="0" y="0"/>
+          <a:chExt cx="0" cy="0"/>
+        </a:xfrm>
+      </p:grpSpPr>
+      <p:pic>
+        <p:nvPicPr>
+          <p:cNvPr id="2" name="Graphic 1" descr="Cursor with solid fill">
+            <a:extLst>
+              <a:ext uri="{FF2B5EF4-FFF2-40B4-BE49-F238E27FC236}">
+                <a16:creationId xmlns:a16="http://schemas.microsoft.com/office/drawing/2014/main" id="{A091902C-FAF0-88DA-BADF-D4724F27A41B}"/>
+              </a:ext>
+            </a:extLst>
+          </p:cNvPr>
+          <p:cNvPicPr>
+            <a:picLocks noChangeAspect="1"/>
+          </p:cNvPicPr>
+          <p:nvPr/>
+        </p:nvPicPr>
+        <p:blipFill>
+          <a:blip>
+            <a:extLst>
+              <a:ext uri="{96DAC541-7B7A-43D3-8B79-37D633B846F1}">
+                <asvg:svgBlip xmlns:asvg="http://schemas.microsoft.com/office/drawing/2016/SVG/main" r:embed="rId2"/>
+              </a:ext>
+            </a:extLst>
+          </a:blip>
+          <a:stretch>
+            <a:fillRect/>
+          </a:stretch>
+        </p:blipFill>
+        <p:spPr>
+          <a:xfrm>
+            <a:off x="-2208061" y="720090"/>
+            <a:ext cx="877824" cy="877824"/>
+          </a:xfrm>
+          <a:prstGeom prst="rect">
+            <a:avLst/>
+          </a:prstGeom>
+        </p:spPr>
+      </p:pic>
+      <p:pic>
+        <p:nvPicPr>
+          <p:cNvPr id="3" name="Graphic 2">
+            <a:extLst>
+              <a:ext uri="{FF2B5EF4-FFF2-40B4-BE49-F238E27FC236}">
+                <a16:creationId xmlns:a16="http://schemas.microsoft.com/office/drawing/2014/main" id="{D3922A1E-66AA-561F-8D68-E2F2EF9AB725}"/>
+              </a:ext>
+            </a:extLst>
+          </p:cNvPr>
+          <p:cNvPicPr>
+            <a:picLocks noChangeAspect="1"/>
+          </p:cNvPicPr>
+          <p:nvPr/>
+        </p:nvPicPr>
+        <p:blipFill>
+          <a:blip>
+            <a:extLst>
+              <a:ext uri="{96DAC541-7B7A-43D3-8B79-37D633B846F1}">
+                <asvg:svgBlip xmlns:asvg="http://schemas.microsoft.com/office/drawing/2016/SVG/main" r:embed="rId3"/>
+              </a:ext>
+            </a:extLst>
+          </a:blip>
+          <a:srcRect/>
+          <a:stretch/>
+        </p:blipFill>
+        <p:spPr>
+          <a:xfrm>
+            <a:off x="0" y="0"/>
+            <a:ext cx="1371600" cy="1371600"/>
+          </a:xfrm>
+          <a:prstGeom prst="rect">
+            <a:avLst/>
+          </a:prstGeom>
+        </p:spPr>
+      </p:pic>
+      <p:sp>
+        <p:nvSpPr>
+          <p:cNvPr id="5" name="TextBox 4">
+            <a:extLst>
+              <a:ext uri="{FF2B5EF4-FFF2-40B4-BE49-F238E27FC236}">
+                <a16:creationId xmlns:a16="http://schemas.microsoft.com/office/drawing/2014/main" id="{C47D40B4-F6B4-7BAD-3D0E-6059ABEA5EEB}"/>
+              </a:ext>
+            </a:extLst>
+          </p:cNvPr>
+          <p:cNvSpPr txBox="1"/>
+          <p:nvPr/>
+        </p:nvSpPr>
+        <p:spPr>
+          <a:xfrm>
+            <a:off x="340519" y="123943"/>
+            <a:ext cx="685800" cy="685800"/>
+          </a:xfrm>
+          <a:prstGeom prst="rect">
+            <a:avLst/>
+          </a:prstGeom>
+          <a:noFill/>
+        </p:spPr>
+        <p:txBody>
+          <a:bodyPr wrap="square" rtlCol="0" anchor="ctr">
+            <a:noAutofit/>
+          </a:bodyPr>
+          <a:lstStyle/>
+          <a:p>
+            <a:pPr algn="ctr"/>
+            <a:r>
+              <a:rPr lang="en-US" sz="800" b="1" dirty="0">
+                <a:latin typeface="Arial" panose="020B0604020202020204" pitchFamily="34" charset="0"/>
+                <a:cs typeface="Arial" panose="020B0604020202020204" pitchFamily="34" charset="0"/>
+              </a:rPr>
+              <a:t>Best</a:t>
+            </a:r>
+            <a:br>
+              <a:rPr lang="en-US" sz="800" b="1" dirty="0">
+                <a:latin typeface="Arial" panose="020B0604020202020204" pitchFamily="34" charset="0"/>
+                <a:cs typeface="Arial" panose="020B0604020202020204" pitchFamily="34" charset="0"/>
+              </a:rPr>
+            </a:br>
+            <a:r>
+              <a:rPr lang="en-US" sz="800" b="1" dirty="0">
+                <a:latin typeface="Arial" panose="020B0604020202020204" pitchFamily="34" charset="0"/>
+                <a:cs typeface="Arial" panose="020B0604020202020204" pitchFamily="34" charset="0"/>
+              </a:rPr>
+              <a:t>Paper</a:t>
+            </a:r>
+            <a:br>
+              <a:rPr lang="en-US" sz="800" b="1" dirty="0">
+                <a:latin typeface="Arial" panose="020B0604020202020204" pitchFamily="34" charset="0"/>
+                <a:cs typeface="Arial" panose="020B0604020202020204" pitchFamily="34" charset="0"/>
+              </a:rPr>
+            </a:br>
+            <a:r>
+              <a:rPr lang="en-US" sz="800" b="1" dirty="0">
+                <a:latin typeface="Arial" panose="020B0604020202020204" pitchFamily="34" charset="0"/>
+                <a:cs typeface="Arial" panose="020B0604020202020204" pitchFamily="34" charset="0"/>
+              </a:rPr>
+              <a:t>Finalist</a:t>
+            </a:r>
+          </a:p>
+        </p:txBody>
+      </p:sp>
+    </p:spTree>
+    <p:extLst>
+      <p:ext uri="{BB962C8B-B14F-4D97-AF65-F5344CB8AC3E}">
+        <p14:creationId xmlns:p14="http://schemas.microsoft.com/office/powerpoint/2010/main" val="1879470490"/>
+      </p:ext>
+    </p:extLst>
+  </p:cSld>
+  <p:clrMapOvr>
+    <a:masterClrMapping/>
+  </p:clrMapOvr>
+</p:sld>
+</file>
+
+<file path=ppt/slides/slide5.xml><?xml version="1.0" encoding="utf-8"?>
 <p:sld xmlns:a="http://schemas.openxmlformats.org/drawingml/2006/main" xmlns:r="http://schemas.openxmlformats.org/officeDocument/2006/relationships" xmlns:p="http://schemas.openxmlformats.org/presentationml/2006/main">
   <p:cSld>
     <p:spTree>
@@ -3827,7 +4193,7 @@
 </p:sld>
 </file>
 
-<file path=ppt/slides/slide4.xml><?xml version="1.0" encoding="utf-8"?>
+<file path=ppt/slides/slide6.xml><?xml version="1.0" encoding="utf-8"?>
 <p:sld xmlns:a="http://schemas.openxmlformats.org/drawingml/2006/main" xmlns:r="http://schemas.openxmlformats.org/officeDocument/2006/relationships" xmlns:p="http://schemas.openxmlformats.org/presentationml/2006/main">
   <p:cSld>
     <p:spTree>
@@ -3990,6 +4356,238 @@
     <p:extLst>
       <p:ext uri="{BB962C8B-B14F-4D97-AF65-F5344CB8AC3E}">
         <p14:creationId xmlns:p14="http://schemas.microsoft.com/office/powerpoint/2010/main" val="3676307321"/>
+      </p:ext>
+    </p:extLst>
+  </p:cSld>
+  <p:clrMapOvr>
+    <a:masterClrMapping/>
+  </p:clrMapOvr>
+</p:sld>
+</file>
+
+<file path=ppt/slides/slide7.xml><?xml version="1.0" encoding="utf-8"?>
+<p:sld xmlns:a="http://schemas.openxmlformats.org/drawingml/2006/main" xmlns:r="http://schemas.openxmlformats.org/officeDocument/2006/relationships" xmlns:p="http://schemas.openxmlformats.org/presentationml/2006/main">
+  <p:cSld>
+    <p:spTree>
+      <p:nvGrpSpPr>
+        <p:cNvPr id="1" name="">
+          <a:extLst>
+            <a:ext uri="{FF2B5EF4-FFF2-40B4-BE49-F238E27FC236}">
+              <a16:creationId xmlns:a16="http://schemas.microsoft.com/office/drawing/2014/main" id="{D46A6A4C-3348-7D99-FA79-CCC7901FDC41}"/>
+            </a:ext>
+          </a:extLst>
+        </p:cNvPr>
+        <p:cNvGrpSpPr/>
+        <p:nvPr/>
+      </p:nvGrpSpPr>
+      <p:grpSpPr>
+        <a:xfrm>
+          <a:off x="0" y="0"/>
+          <a:ext cx="0" cy="0"/>
+          <a:chOff x="0" y="0"/>
+          <a:chExt cx="0" cy="0"/>
+        </a:xfrm>
+      </p:grpSpPr>
+      <p:pic>
+        <p:nvPicPr>
+          <p:cNvPr id="2" name="Graphic 1" descr="Cursor with solid fill">
+            <a:extLst>
+              <a:ext uri="{FF2B5EF4-FFF2-40B4-BE49-F238E27FC236}">
+                <a16:creationId xmlns:a16="http://schemas.microsoft.com/office/drawing/2014/main" id="{02C84DE5-81F5-A02A-4C94-A5844910D812}"/>
+              </a:ext>
+            </a:extLst>
+          </p:cNvPr>
+          <p:cNvPicPr>
+            <a:picLocks noChangeAspect="1"/>
+          </p:cNvPicPr>
+          <p:nvPr/>
+        </p:nvPicPr>
+        <p:blipFill>
+          <a:blip>
+            <a:extLst>
+              <a:ext uri="{96DAC541-7B7A-43D3-8B79-37D633B846F1}">
+                <asvg:svgBlip xmlns:asvg="http://schemas.microsoft.com/office/drawing/2016/SVG/main" r:embed="rId2"/>
+              </a:ext>
+            </a:extLst>
+          </a:blip>
+          <a:stretch>
+            <a:fillRect/>
+          </a:stretch>
+        </p:blipFill>
+        <p:spPr>
+          <a:xfrm>
+            <a:off x="-2208061" y="720090"/>
+            <a:ext cx="877824" cy="877824"/>
+          </a:xfrm>
+          <a:prstGeom prst="rect">
+            <a:avLst/>
+          </a:prstGeom>
+        </p:spPr>
+      </p:pic>
+      <p:pic>
+        <p:nvPicPr>
+          <p:cNvPr id="3" name="Graphic 2">
+            <a:extLst>
+              <a:ext uri="{FF2B5EF4-FFF2-40B4-BE49-F238E27FC236}">
+                <a16:creationId xmlns:a16="http://schemas.microsoft.com/office/drawing/2014/main" id="{398B8D96-60BA-AC7E-EF46-531F883F2BFF}"/>
+              </a:ext>
+            </a:extLst>
+          </p:cNvPr>
+          <p:cNvPicPr>
+            <a:picLocks noChangeAspect="1"/>
+          </p:cNvPicPr>
+          <p:nvPr/>
+        </p:nvPicPr>
+        <p:blipFill>
+          <a:blip>
+            <a:extLst>
+              <a:ext uri="{96DAC541-7B7A-43D3-8B79-37D633B846F1}">
+                <asvg:svgBlip xmlns:asvg="http://schemas.microsoft.com/office/drawing/2016/SVG/main" r:embed="rId3"/>
+              </a:ext>
+            </a:extLst>
+          </a:blip>
+          <a:srcRect/>
+          <a:stretch/>
+        </p:blipFill>
+        <p:spPr>
+          <a:xfrm>
+            <a:off x="0" y="0"/>
+            <a:ext cx="1371600" cy="1371600"/>
+          </a:xfrm>
+          <a:prstGeom prst="rect">
+            <a:avLst/>
+          </a:prstGeom>
+        </p:spPr>
+      </p:pic>
+      <p:sp>
+        <p:nvSpPr>
+          <p:cNvPr id="5" name="TextBox 4">
+            <a:extLst>
+              <a:ext uri="{FF2B5EF4-FFF2-40B4-BE49-F238E27FC236}">
+                <a16:creationId xmlns:a16="http://schemas.microsoft.com/office/drawing/2014/main" id="{902ABD83-7469-1185-A701-CD546D657196}"/>
+              </a:ext>
+            </a:extLst>
+          </p:cNvPr>
+          <p:cNvSpPr txBox="1"/>
+          <p:nvPr/>
+        </p:nvSpPr>
+        <p:spPr>
+          <a:xfrm>
+            <a:off x="340519" y="123943"/>
+            <a:ext cx="685800" cy="685800"/>
+          </a:xfrm>
+          <a:prstGeom prst="rect">
+            <a:avLst/>
+          </a:prstGeom>
+          <a:noFill/>
+        </p:spPr>
+        <p:txBody>
+          <a:bodyPr wrap="square" rtlCol="0" anchor="ctr">
+            <a:noAutofit/>
+          </a:bodyPr>
+          <a:lstStyle/>
+          <a:p>
+            <a:pPr algn="ctr"/>
+            <a:r>
+              <a:rPr lang="en-US" sz="800" b="1" dirty="0">
+                <a:latin typeface="Arial" panose="020B0604020202020204" pitchFamily="34" charset="0"/>
+                <a:cs typeface="Arial" panose="020B0604020202020204" pitchFamily="34" charset="0"/>
+              </a:rPr>
+              <a:t>Best</a:t>
+            </a:r>
+            <a:br>
+              <a:rPr lang="en-US" sz="800" b="1" dirty="0">
+                <a:latin typeface="Arial" panose="020B0604020202020204" pitchFamily="34" charset="0"/>
+                <a:cs typeface="Arial" panose="020B0604020202020204" pitchFamily="34" charset="0"/>
+              </a:rPr>
+            </a:br>
+            <a:r>
+              <a:rPr lang="en-US" sz="800" b="1" dirty="0">
+                <a:latin typeface="Arial" panose="020B0604020202020204" pitchFamily="34" charset="0"/>
+                <a:cs typeface="Arial" panose="020B0604020202020204" pitchFamily="34" charset="0"/>
+              </a:rPr>
+              <a:t>Paper</a:t>
+            </a:r>
+            <a:br>
+              <a:rPr lang="en-US" sz="800" b="1" dirty="0">
+                <a:latin typeface="Arial" panose="020B0604020202020204" pitchFamily="34" charset="0"/>
+                <a:cs typeface="Arial" panose="020B0604020202020204" pitchFamily="34" charset="0"/>
+              </a:rPr>
+            </a:br>
+            <a:r>
+              <a:rPr lang="en-US" sz="800" b="1" dirty="0">
+                <a:latin typeface="Arial" panose="020B0604020202020204" pitchFamily="34" charset="0"/>
+                <a:cs typeface="Arial" panose="020B0604020202020204" pitchFamily="34" charset="0"/>
+              </a:rPr>
+              <a:t>Finalist</a:t>
+            </a:r>
+          </a:p>
+        </p:txBody>
+      </p:sp>
+      <p:sp>
+        <p:nvSpPr>
+          <p:cNvPr id="6" name="Rectangle 5">
+            <a:extLst>
+              <a:ext uri="{FF2B5EF4-FFF2-40B4-BE49-F238E27FC236}">
+                <a16:creationId xmlns:a16="http://schemas.microsoft.com/office/drawing/2014/main" id="{49FA4DA5-66C6-FE5D-F6E1-5E238F3E3DC8}"/>
+              </a:ext>
+            </a:extLst>
+          </p:cNvPr>
+          <p:cNvSpPr/>
+          <p:nvPr/>
+        </p:nvSpPr>
+        <p:spPr>
+          <a:xfrm>
+            <a:off x="226219" y="750806"/>
+            <a:ext cx="914400" cy="365760"/>
+          </a:xfrm>
+          <a:prstGeom prst="rect">
+            <a:avLst/>
+          </a:prstGeom>
+        </p:spPr>
+        <p:style>
+          <a:lnRef idx="2">
+            <a:schemeClr val="accent1">
+              <a:shade val="15000"/>
+            </a:schemeClr>
+          </a:lnRef>
+          <a:fillRef idx="1">
+            <a:schemeClr val="accent1"/>
+          </a:fillRef>
+          <a:effectRef idx="0">
+            <a:schemeClr val="accent1"/>
+          </a:effectRef>
+          <a:fontRef idx="minor">
+            <a:schemeClr val="lt1"/>
+          </a:fontRef>
+        </p:style>
+        <p:txBody>
+          <a:bodyPr rtlCol="0" anchor="ctr"/>
+          <a:lstStyle/>
+          <a:p>
+            <a:pPr algn="ctr">
+              <a:spcAft>
+                <a:spcPts val="150"/>
+              </a:spcAft>
+            </a:pPr>
+            <a:r>
+              <a:rPr lang="en-US" sz="400" dirty="0"/>
+              <a:t>2026 Academy of Management (AOM) Conference</a:t>
+            </a:r>
+          </a:p>
+          <a:p>
+            <a:pPr algn="ctr"/>
+            <a:r>
+              <a:rPr lang="en-US" sz="400" dirty="0"/>
+              <a:t>Managerial and Organizational Cognition (MOC) Division </a:t>
+            </a:r>
+          </a:p>
+        </p:txBody>
+      </p:sp>
+    </p:spTree>
+    <p:extLst>
+      <p:ext uri="{BB962C8B-B14F-4D97-AF65-F5344CB8AC3E}">
+        <p14:creationId xmlns:p14="http://schemas.microsoft.com/office/powerpoint/2010/main" val="3136558285"/>
       </p:ext>
     </p:extLst>
   </p:cSld>

</xml_diff>

<commit_message>
AOM MOC award status update
</commit_message>
<xml_diff>
--- a/images/awards.pptx
+++ b/images/awards.pptx
@@ -16,7 +16,7 @@
     <p:sldId id="262" r:id="rId7"/>
     <p:sldId id="264" r:id="rId8"/>
     <p:sldId id="269" r:id="rId9"/>
-    <p:sldId id="267" r:id="rId10"/>
+    <p:sldId id="271" r:id="rId10"/>
     <p:sldId id="268" r:id="rId11"/>
   </p:sldIdLst>
   <p:sldSz cx="1371600" cy="1371600"/>
@@ -133,7 +133,7 @@
         </p14:section>
         <p14:section name="Specific Awards" id="{B204BF1A-F5DA-4780-BD4D-6DBA4BFC239A}">
           <p14:sldIdLst>
-            <p14:sldId id="267"/>
+            <p14:sldId id="271"/>
             <p14:sldId id="268"/>
           </p14:sldIdLst>
         </p14:section>
@@ -228,7 +228,7 @@
           <a:p>
             <a:fld id="{B1913588-C2C1-4AB8-9F0D-04EC72C1EC15}" type="datetimeFigureOut">
               <a:rPr lang="en-US" smtClean="0"/>
-              <a:t>7/7/2026</a:t>
+              <a:t>8/3/2026</a:t>
             </a:fld>
             <a:endParaRPr lang="en-US"/>
           </a:p>
@@ -626,7 +626,7 @@
           <a:p>
             <a:fld id="{B8700A39-06E1-486D-9C71-A159ABBEACA4}" type="datetimeFigureOut">
               <a:rPr lang="en-US" smtClean="0"/>
-              <a:t>7/7/2026</a:t>
+              <a:t>8/3/2026</a:t>
             </a:fld>
             <a:endParaRPr lang="en-US"/>
           </a:p>
@@ -796,7 +796,7 @@
           <a:p>
             <a:fld id="{B8700A39-06E1-486D-9C71-A159ABBEACA4}" type="datetimeFigureOut">
               <a:rPr lang="en-US" smtClean="0"/>
-              <a:t>7/7/2026</a:t>
+              <a:t>8/3/2026</a:t>
             </a:fld>
             <a:endParaRPr lang="en-US"/>
           </a:p>
@@ -976,7 +976,7 @@
           <a:p>
             <a:fld id="{B8700A39-06E1-486D-9C71-A159ABBEACA4}" type="datetimeFigureOut">
               <a:rPr lang="en-US" smtClean="0"/>
-              <a:t>7/7/2026</a:t>
+              <a:t>8/3/2026</a:t>
             </a:fld>
             <a:endParaRPr lang="en-US"/>
           </a:p>
@@ -1146,7 +1146,7 @@
           <a:p>
             <a:fld id="{B8700A39-06E1-486D-9C71-A159ABBEACA4}" type="datetimeFigureOut">
               <a:rPr lang="en-US" smtClean="0"/>
-              <a:t>7/7/2026</a:t>
+              <a:t>8/3/2026</a:t>
             </a:fld>
             <a:endParaRPr lang="en-US"/>
           </a:p>
@@ -1392,7 +1392,7 @@
           <a:p>
             <a:fld id="{B8700A39-06E1-486D-9C71-A159ABBEACA4}" type="datetimeFigureOut">
               <a:rPr lang="en-US" smtClean="0"/>
-              <a:t>7/7/2026</a:t>
+              <a:t>8/3/2026</a:t>
             </a:fld>
             <a:endParaRPr lang="en-US"/>
           </a:p>
@@ -1624,7 +1624,7 @@
           <a:p>
             <a:fld id="{B8700A39-06E1-486D-9C71-A159ABBEACA4}" type="datetimeFigureOut">
               <a:rPr lang="en-US" smtClean="0"/>
-              <a:t>7/7/2026</a:t>
+              <a:t>8/3/2026</a:t>
             </a:fld>
             <a:endParaRPr lang="en-US"/>
           </a:p>
@@ -1991,7 +1991,7 @@
           <a:p>
             <a:fld id="{B8700A39-06E1-486D-9C71-A159ABBEACA4}" type="datetimeFigureOut">
               <a:rPr lang="en-US" smtClean="0"/>
-              <a:t>7/7/2026</a:t>
+              <a:t>8/3/2026</a:t>
             </a:fld>
             <a:endParaRPr lang="en-US"/>
           </a:p>
@@ -2109,7 +2109,7 @@
           <a:p>
             <a:fld id="{B8700A39-06E1-486D-9C71-A159ABBEACA4}" type="datetimeFigureOut">
               <a:rPr lang="en-US" smtClean="0"/>
-              <a:t>7/7/2026</a:t>
+              <a:t>8/3/2026</a:t>
             </a:fld>
             <a:endParaRPr lang="en-US"/>
           </a:p>
@@ -2204,7 +2204,7 @@
           <a:p>
             <a:fld id="{B8700A39-06E1-486D-9C71-A159ABBEACA4}" type="datetimeFigureOut">
               <a:rPr lang="en-US" smtClean="0"/>
-              <a:t>7/7/2026</a:t>
+              <a:t>8/3/2026</a:t>
             </a:fld>
             <a:endParaRPr lang="en-US"/>
           </a:p>
@@ -2481,7 +2481,7 @@
           <a:p>
             <a:fld id="{B8700A39-06E1-486D-9C71-A159ABBEACA4}" type="datetimeFigureOut">
               <a:rPr lang="en-US" smtClean="0"/>
-              <a:t>7/7/2026</a:t>
+              <a:t>8/3/2026</a:t>
             </a:fld>
             <a:endParaRPr lang="en-US"/>
           </a:p>
@@ -2738,7 +2738,7 @@
           <a:p>
             <a:fld id="{B8700A39-06E1-486D-9C71-A159ABBEACA4}" type="datetimeFigureOut">
               <a:rPr lang="en-US" smtClean="0"/>
-              <a:t>7/7/2026</a:t>
+              <a:t>8/3/2026</a:t>
             </a:fld>
             <a:endParaRPr lang="en-US"/>
           </a:p>
@@ -2951,7 +2951,7 @@
           <a:p>
             <a:fld id="{B8700A39-06E1-486D-9C71-A159ABBEACA4}" type="datetimeFigureOut">
               <a:rPr lang="en-US" smtClean="0"/>
-              <a:t>7/7/2026</a:t>
+              <a:t>8/3/2026</a:t>
             </a:fld>
             <a:endParaRPr lang="en-US"/>
           </a:p>
@@ -5088,7 +5088,7 @@
         <p:cNvPr id="1" name="">
           <a:extLst>
             <a:ext uri="{FF2B5EF4-FFF2-40B4-BE49-F238E27FC236}">
-              <a16:creationId xmlns:a16="http://schemas.microsoft.com/office/drawing/2014/main" id="{D46A6A4C-3348-7D99-FA79-CCC7901FDC41}"/>
+              <a16:creationId xmlns:a16="http://schemas.microsoft.com/office/drawing/2014/main" id="{FC79B78F-6DCC-DB66-B843-689A88D28980}"/>
             </a:ext>
           </a:extLst>
         </p:cNvPr>
@@ -5108,7 +5108,7 @@
           <p:cNvPr id="2" name="Graphic 1" descr="Cursor with solid fill">
             <a:extLst>
               <a:ext uri="{FF2B5EF4-FFF2-40B4-BE49-F238E27FC236}">
-                <a16:creationId xmlns:a16="http://schemas.microsoft.com/office/drawing/2014/main" id="{02C84DE5-81F5-A02A-4C94-A5844910D812}"/>
+                <a16:creationId xmlns:a16="http://schemas.microsoft.com/office/drawing/2014/main" id="{58AF0F15-BEA5-AC19-4B24-91E56830CA9D}"/>
               </a:ext>
             </a:extLst>
           </p:cNvPr>
@@ -5144,7 +5144,7 @@
           <p:cNvPr id="3" name="Graphic 2">
             <a:extLst>
               <a:ext uri="{FF2B5EF4-FFF2-40B4-BE49-F238E27FC236}">
-                <a16:creationId xmlns:a16="http://schemas.microsoft.com/office/drawing/2014/main" id="{398B8D96-60BA-AC7E-EF46-531F883F2BFF}"/>
+                <a16:creationId xmlns:a16="http://schemas.microsoft.com/office/drawing/2014/main" id="{58F3FD9C-D621-1E2E-F02C-386BEAD75C6A}"/>
               </a:ext>
             </a:extLst>
           </p:cNvPr>
@@ -5179,7 +5179,7 @@
           <p:cNvPr id="5" name="TextBox 4">
             <a:extLst>
               <a:ext uri="{FF2B5EF4-FFF2-40B4-BE49-F238E27FC236}">
-                <a16:creationId xmlns:a16="http://schemas.microsoft.com/office/drawing/2014/main" id="{902ABD83-7469-1185-A701-CD546D657196}"/>
+                <a16:creationId xmlns:a16="http://schemas.microsoft.com/office/drawing/2014/main" id="{0CEDEC67-A86E-7370-F438-434E1EE19E8B}"/>
               </a:ext>
             </a:extLst>
           </p:cNvPr>
@@ -5249,7 +5249,7 @@
                 <a:latin typeface="Arial" panose="020B0604020202020204" pitchFamily="34" charset="0"/>
                 <a:cs typeface="Arial" panose="020B0604020202020204" pitchFamily="34" charset="0"/>
               </a:rPr>
-              <a:t>Finalist</a:t>
+              <a:t>Winner</a:t>
             </a:r>
           </a:p>
         </p:txBody>
@@ -5259,7 +5259,7 @@
           <p:cNvPr id="6" name="Rectangle: Diagonal Corners Rounded 5">
             <a:extLst>
               <a:ext uri="{FF2B5EF4-FFF2-40B4-BE49-F238E27FC236}">
-                <a16:creationId xmlns:a16="http://schemas.microsoft.com/office/drawing/2014/main" id="{49FA4DA5-66C6-FE5D-F6E1-5E238F3E3DC8}"/>
+                <a16:creationId xmlns:a16="http://schemas.microsoft.com/office/drawing/2014/main" id="{94A835A1-6038-CDFB-6922-F8247914AF94}"/>
               </a:ext>
             </a:extLst>
           </p:cNvPr>
@@ -5325,7 +5325,7 @@
     </p:spTree>
     <p:extLst>
       <p:ext uri="{BB962C8B-B14F-4D97-AF65-F5344CB8AC3E}">
-        <p14:creationId xmlns:p14="http://schemas.microsoft.com/office/powerpoint/2010/main" val="3136558285"/>
+        <p14:creationId xmlns:p14="http://schemas.microsoft.com/office/powerpoint/2010/main" val="400550204"/>
       </p:ext>
     </p:extLst>
   </p:cSld>

</xml_diff>